<commit_message>
update result for deepgaze
</commit_message>
<xml_diff>
--- a/Presentation/FYP_NguyenTuan_Presentation.pptx
+++ b/Presentation/FYP_NguyenTuan_Presentation.pptx
@@ -3622,7 +3622,7 @@
           <a:p>
             <a:fld id="{9A9C0C59-185E-874E-8468-6092D83992DA}" type="datetimeFigureOut">
               <a:rPr lang="en-US" smtClean="0"/>
-              <a:t>4/15/26</a:t>
+              <a:t>4/30/26</a:t>
             </a:fld>
             <a:endParaRPr lang="en-US"/>
           </a:p>
@@ -7451,7 +7451,7 @@
           <a:p>
             <a:fld id="{D1D1EADE-8E88-4C7C-8AC5-FB148DE4940E}" type="datetime1">
               <a:rPr lang="en-US" smtClean="0"/>
-              <a:t>4/15/26</a:t>
+              <a:t>4/30/26</a:t>
             </a:fld>
             <a:endParaRPr lang="en-US"/>
           </a:p>
@@ -7651,7 +7651,7 @@
           <a:p>
             <a:fld id="{EC3C8B9C-477D-492A-96AD-1FC2CC997A73}" type="datetime1">
               <a:rPr lang="en-US" smtClean="0"/>
-              <a:t>4/15/26</a:t>
+              <a:t>4/30/26</a:t>
             </a:fld>
             <a:endParaRPr lang="en-US"/>
           </a:p>
@@ -7861,7 +7861,7 @@
           <a:p>
             <a:fld id="{42D3AED5-E26D-4E29-B1B3-7847B6779594}" type="datetime1">
               <a:rPr lang="en-US" smtClean="0"/>
-              <a:t>4/15/26</a:t>
+              <a:t>4/30/26</a:t>
             </a:fld>
             <a:endParaRPr lang="en-US"/>
           </a:p>
@@ -8061,7 +8061,7 @@
           <a:p>
             <a:fld id="{157B6794-849E-4626-908B-D15793550EFB}" type="datetime1">
               <a:rPr lang="en-US" smtClean="0"/>
-              <a:t>4/15/26</a:t>
+              <a:t>4/30/26</a:t>
             </a:fld>
             <a:endParaRPr lang="en-US"/>
           </a:p>
@@ -8337,7 +8337,7 @@
           <a:p>
             <a:fld id="{63DB64E7-5594-42A3-ADBF-E95A7ACEAD64}" type="datetime1">
               <a:rPr lang="en-US" smtClean="0"/>
-              <a:t>4/15/26</a:t>
+              <a:t>4/30/26</a:t>
             </a:fld>
             <a:endParaRPr lang="en-US"/>
           </a:p>
@@ -8610,7 +8610,7 @@
           <a:p>
             <a:fld id="{18462B0B-D248-4FFB-8695-AD7FA4B1284A}" type="datetime1">
               <a:rPr lang="en-US" smtClean="0"/>
-              <a:t>4/15/26</a:t>
+              <a:t>4/30/26</a:t>
             </a:fld>
             <a:endParaRPr lang="en-US"/>
           </a:p>
@@ -9033,7 +9033,7 @@
           <a:p>
             <a:fld id="{D0378EFB-9159-4510-B73F-4F0409ADE937}" type="datetime1">
               <a:rPr lang="en-US" smtClean="0"/>
-              <a:t>4/15/26</a:t>
+              <a:t>4/30/26</a:t>
             </a:fld>
             <a:endParaRPr lang="en-US"/>
           </a:p>
@@ -9175,7 +9175,7 @@
           <a:p>
             <a:fld id="{89BC9412-2452-4BED-A324-9D8C115361AD}" type="datetime1">
               <a:rPr lang="en-US" smtClean="0"/>
-              <a:t>4/15/26</a:t>
+              <a:t>4/30/26</a:t>
             </a:fld>
             <a:endParaRPr lang="en-US"/>
           </a:p>
@@ -9288,7 +9288,7 @@
           <a:p>
             <a:fld id="{F5318F62-D251-40E8-A23C-F4CFE9FEAB41}" type="datetime1">
               <a:rPr lang="en-US" smtClean="0"/>
-              <a:t>4/15/26</a:t>
+              <a:t>4/30/26</a:t>
             </a:fld>
             <a:endParaRPr lang="en-US"/>
           </a:p>
@@ -9601,7 +9601,7 @@
           <a:p>
             <a:fld id="{44F76144-149E-4874-93A5-554A0357CF82}" type="datetime1">
               <a:rPr lang="en-US" smtClean="0"/>
-              <a:t>4/15/26</a:t>
+              <a:t>4/30/26</a:t>
             </a:fld>
             <a:endParaRPr lang="en-US"/>
           </a:p>
@@ -9894,7 +9894,7 @@
           <a:p>
             <a:fld id="{50BA65D8-0540-4835-AE5C-25D29DBA01BE}" type="datetime1">
               <a:rPr lang="en-US" smtClean="0"/>
-              <a:t>4/15/26</a:t>
+              <a:t>4/30/26</a:t>
             </a:fld>
             <a:endParaRPr lang="en-US"/>
           </a:p>
@@ -10136,7 +10136,7 @@
           <a:p>
             <a:fld id="{E31BA835-12AC-4E8F-955A-EA3F4DE2791F}" type="datetime1">
               <a:rPr lang="en-US" smtClean="0"/>
-              <a:t>4/15/26</a:t>
+              <a:t>4/30/26</a:t>
             </a:fld>
             <a:endParaRPr lang="en-US"/>
           </a:p>

</xml_diff>

<commit_message>
update with IVSN notebooks
</commit_message>
<xml_diff>
--- a/Presentation/FYP_NguyenTuan_Presentation.pptx
+++ b/Presentation/FYP_NguyenTuan_Presentation.pptx
@@ -5,7 +5,7 @@
     <p:sldMasterId id="2147483863" r:id="rId1"/>
   </p:sldMasterIdLst>
   <p:notesMasterIdLst>
-    <p:notesMasterId r:id="rId42"/>
+    <p:notesMasterId r:id="rId43"/>
   </p:notesMasterIdLst>
   <p:sldIdLst>
     <p:sldId id="256" r:id="rId2"/>
@@ -48,6 +48,7 @@
     <p:sldId id="294" r:id="rId39"/>
     <p:sldId id="295" r:id="rId40"/>
     <p:sldId id="296" r:id="rId41"/>
+    <p:sldId id="297" r:id="rId42"/>
   </p:sldIdLst>
   <p:sldSz cx="12192000" cy="6858000"/>
   <p:notesSz cx="6858000" cy="9144000"/>
@@ -3622,7 +3623,7 @@
           <a:p>
             <a:fld id="{9A9C0C59-185E-874E-8468-6092D83992DA}" type="datetimeFigureOut">
               <a:rPr lang="en-US" smtClean="0"/>
-              <a:t>4/30/26</a:t>
+              <a:t>5/3/26</a:t>
             </a:fld>
             <a:endParaRPr lang="en-US"/>
           </a:p>
@@ -7451,7 +7452,7 @@
           <a:p>
             <a:fld id="{D1D1EADE-8E88-4C7C-8AC5-FB148DE4940E}" type="datetime1">
               <a:rPr lang="en-US" smtClean="0"/>
-              <a:t>4/30/26</a:t>
+              <a:t>5/3/26</a:t>
             </a:fld>
             <a:endParaRPr lang="en-US"/>
           </a:p>
@@ -7651,7 +7652,7 @@
           <a:p>
             <a:fld id="{EC3C8B9C-477D-492A-96AD-1FC2CC997A73}" type="datetime1">
               <a:rPr lang="en-US" smtClean="0"/>
-              <a:t>4/30/26</a:t>
+              <a:t>5/3/26</a:t>
             </a:fld>
             <a:endParaRPr lang="en-US"/>
           </a:p>
@@ -7861,7 +7862,7 @@
           <a:p>
             <a:fld id="{42D3AED5-E26D-4E29-B1B3-7847B6779594}" type="datetime1">
               <a:rPr lang="en-US" smtClean="0"/>
-              <a:t>4/30/26</a:t>
+              <a:t>5/3/26</a:t>
             </a:fld>
             <a:endParaRPr lang="en-US"/>
           </a:p>
@@ -8061,7 +8062,7 @@
           <a:p>
             <a:fld id="{157B6794-849E-4626-908B-D15793550EFB}" type="datetime1">
               <a:rPr lang="en-US" smtClean="0"/>
-              <a:t>4/30/26</a:t>
+              <a:t>5/3/26</a:t>
             </a:fld>
             <a:endParaRPr lang="en-US"/>
           </a:p>
@@ -8337,7 +8338,7 @@
           <a:p>
             <a:fld id="{63DB64E7-5594-42A3-ADBF-E95A7ACEAD64}" type="datetime1">
               <a:rPr lang="en-US" smtClean="0"/>
-              <a:t>4/30/26</a:t>
+              <a:t>5/3/26</a:t>
             </a:fld>
             <a:endParaRPr lang="en-US"/>
           </a:p>
@@ -8610,7 +8611,7 @@
           <a:p>
             <a:fld id="{18462B0B-D248-4FFB-8695-AD7FA4B1284A}" type="datetime1">
               <a:rPr lang="en-US" smtClean="0"/>
-              <a:t>4/30/26</a:t>
+              <a:t>5/3/26</a:t>
             </a:fld>
             <a:endParaRPr lang="en-US"/>
           </a:p>
@@ -9033,7 +9034,7 @@
           <a:p>
             <a:fld id="{D0378EFB-9159-4510-B73F-4F0409ADE937}" type="datetime1">
               <a:rPr lang="en-US" smtClean="0"/>
-              <a:t>4/30/26</a:t>
+              <a:t>5/3/26</a:t>
             </a:fld>
             <a:endParaRPr lang="en-US"/>
           </a:p>
@@ -9175,7 +9176,7 @@
           <a:p>
             <a:fld id="{89BC9412-2452-4BED-A324-9D8C115361AD}" type="datetime1">
               <a:rPr lang="en-US" smtClean="0"/>
-              <a:t>4/30/26</a:t>
+              <a:t>5/3/26</a:t>
             </a:fld>
             <a:endParaRPr lang="en-US"/>
           </a:p>
@@ -9288,7 +9289,7 @@
           <a:p>
             <a:fld id="{F5318F62-D251-40E8-A23C-F4CFE9FEAB41}" type="datetime1">
               <a:rPr lang="en-US" smtClean="0"/>
-              <a:t>4/30/26</a:t>
+              <a:t>5/3/26</a:t>
             </a:fld>
             <a:endParaRPr lang="en-US"/>
           </a:p>
@@ -9601,7 +9602,7 @@
           <a:p>
             <a:fld id="{44F76144-149E-4874-93A5-554A0357CF82}" type="datetime1">
               <a:rPr lang="en-US" smtClean="0"/>
-              <a:t>4/30/26</a:t>
+              <a:t>5/3/26</a:t>
             </a:fld>
             <a:endParaRPr lang="en-US"/>
           </a:p>
@@ -9894,7 +9895,7 @@
           <a:p>
             <a:fld id="{50BA65D8-0540-4835-AE5C-25D29DBA01BE}" type="datetime1">
               <a:rPr lang="en-US" smtClean="0"/>
-              <a:t>4/30/26</a:t>
+              <a:t>5/3/26</a:t>
             </a:fld>
             <a:endParaRPr lang="en-US"/>
           </a:p>
@@ -10136,7 +10137,7 @@
           <a:p>
             <a:fld id="{E31BA835-12AC-4E8F-955A-EA3F4DE2791F}" type="datetime1">
               <a:rPr lang="en-US" smtClean="0"/>
-              <a:t>4/30/26</a:t>
+              <a:t>5/3/26</a:t>
             </a:fld>
             <a:endParaRPr lang="en-US"/>
           </a:p>
@@ -35291,7 +35292,23 @@
           <a:p>
             <a:r>
               <a:rPr lang="en-US" dirty="0"/>
-              <a:t>Data Augmentation for CRT training</a:t>
+              <a:t>Data Augmentation for </a:t>
+            </a:r>
+            <a:r>
+              <a:rPr lang="en-US" dirty="0" err="1"/>
+              <a:t>CRTNet</a:t>
+            </a:r>
+            <a:r>
+              <a:rPr lang="en-US" dirty="0"/>
+              <a:t> </a:t>
+            </a:r>
+            <a:r>
+              <a:rPr lang="en-US" dirty="0">
+                <a:solidFill>
+                  <a:srgbClr val="FF0000"/>
+                </a:solidFill>
+              </a:rPr>
+              <a:t>training</a:t>
             </a:r>
           </a:p>
         </p:txBody>
@@ -35302,6 +35319,315 @@
             <a:extLst>
               <a:ext uri="{FF2B5EF4-FFF2-40B4-BE49-F238E27FC236}">
                 <a16:creationId xmlns:a16="http://schemas.microsoft.com/office/drawing/2014/main" id="{DF859578-2424-9E7D-2B6E-706042D5702C}"/>
+              </a:ext>
+            </a:extLst>
+          </p:cNvPr>
+          <p:cNvSpPr>
+            <a:spLocks noGrp="1"/>
+          </p:cNvSpPr>
+          <p:nvPr>
+            <p:ph idx="1"/>
+          </p:nvPr>
+        </p:nvSpPr>
+        <p:spPr>
+          <a:xfrm>
+            <a:off x="700635" y="2221992"/>
+            <a:ext cx="10691265" cy="1701422"/>
+          </a:xfrm>
+        </p:spPr>
+        <p:txBody>
+          <a:bodyPr/>
+          <a:lstStyle/>
+          <a:p>
+            <a:r>
+              <a:rPr lang="en-US" dirty="0"/>
+              <a:t>We select 18 image categories from the COCO dataset </a:t>
+            </a:r>
+            <a:r>
+              <a:rPr lang="en-SG" dirty="0"/>
+              <a:t>(Lin et al., 2015) and conduct augmentation on both context and target images.</a:t>
+            </a:r>
+          </a:p>
+          <a:p>
+            <a:r>
+              <a:rPr lang="en-SG" dirty="0"/>
+              <a:t>There are 3 selections for Context Image and 3 selections for Target Image to form 1 image pair.</a:t>
+            </a:r>
+          </a:p>
+          <a:p>
+            <a:pPr marL="0" indent="0">
+              <a:buNone/>
+            </a:pPr>
+            <a:endParaRPr lang="en-SG" dirty="0"/>
+          </a:p>
+        </p:txBody>
+      </p:sp>
+      <p:sp>
+        <p:nvSpPr>
+          <p:cNvPr id="5" name="TextBox 4">
+            <a:extLst>
+              <a:ext uri="{FF2B5EF4-FFF2-40B4-BE49-F238E27FC236}">
+                <a16:creationId xmlns:a16="http://schemas.microsoft.com/office/drawing/2014/main" id="{95E92041-607D-25AC-6D5E-19F70B7285D7}"/>
+              </a:ext>
+            </a:extLst>
+          </p:cNvPr>
+          <p:cNvSpPr txBox="1"/>
+          <p:nvPr/>
+        </p:nvSpPr>
+        <p:spPr>
+          <a:xfrm>
+            <a:off x="6966985" y="3429000"/>
+            <a:ext cx="4888314" cy="2031325"/>
+          </a:xfrm>
+          <a:prstGeom prst="rect">
+            <a:avLst/>
+          </a:prstGeom>
+          <a:noFill/>
+        </p:spPr>
+        <p:txBody>
+          <a:bodyPr wrap="square">
+            <a:spAutoFit/>
+          </a:bodyPr>
+          <a:lstStyle/>
+          <a:p>
+            <a:pPr marL="0" indent="0">
+              <a:lnSpc>
+                <a:spcPct val="150000"/>
+              </a:lnSpc>
+              <a:buNone/>
+            </a:pPr>
+            <a:r>
+              <a:rPr lang="en-SG" dirty="0"/>
+              <a:t>Target input selections:</a:t>
+            </a:r>
+          </a:p>
+          <a:p>
+            <a:pPr marL="342900" indent="-342900">
+              <a:lnSpc>
+                <a:spcPct val="150000"/>
+              </a:lnSpc>
+              <a:buAutoNum type="arabicParenBoth"/>
+            </a:pPr>
+            <a:r>
+              <a:rPr lang="en-SG" dirty="0"/>
+              <a:t>Original target image.</a:t>
+            </a:r>
+          </a:p>
+          <a:p>
+            <a:pPr marL="342900" indent="-342900">
+              <a:lnSpc>
+                <a:spcPct val="150000"/>
+              </a:lnSpc>
+              <a:buAutoNum type="arabicParenBoth"/>
+            </a:pPr>
+            <a:r>
+              <a:rPr lang="en-SG" dirty="0"/>
+              <a:t>Random target image of the same category.</a:t>
+            </a:r>
+          </a:p>
+          <a:p>
+            <a:pPr marL="342900" indent="-342900">
+              <a:lnSpc>
+                <a:spcPct val="150000"/>
+              </a:lnSpc>
+              <a:buAutoNum type="arabicParenBoth"/>
+            </a:pPr>
+            <a:r>
+              <a:rPr lang="en-SG" dirty="0"/>
+              <a:t>Black rectangle of the target image size.</a:t>
+            </a:r>
+          </a:p>
+          <a:p>
+            <a:pPr marL="342900" indent="-342900">
+              <a:buAutoNum type="arabicParenBoth"/>
+            </a:pPr>
+            <a:endParaRPr lang="en-SG" dirty="0"/>
+          </a:p>
+        </p:txBody>
+      </p:sp>
+      <p:sp>
+        <p:nvSpPr>
+          <p:cNvPr id="6" name="TextBox 5">
+            <a:extLst>
+              <a:ext uri="{FF2B5EF4-FFF2-40B4-BE49-F238E27FC236}">
+                <a16:creationId xmlns:a16="http://schemas.microsoft.com/office/drawing/2014/main" id="{541EBC4E-C588-827E-C1ED-119B33032AEF}"/>
+              </a:ext>
+            </a:extLst>
+          </p:cNvPr>
+          <p:cNvSpPr txBox="1"/>
+          <p:nvPr/>
+        </p:nvSpPr>
+        <p:spPr>
+          <a:xfrm>
+            <a:off x="784924" y="3429000"/>
+            <a:ext cx="6097772" cy="2862322"/>
+          </a:xfrm>
+          <a:prstGeom prst="rect">
+            <a:avLst/>
+          </a:prstGeom>
+          <a:noFill/>
+        </p:spPr>
+        <p:txBody>
+          <a:bodyPr wrap="square">
+            <a:spAutoFit/>
+          </a:bodyPr>
+          <a:lstStyle/>
+          <a:p>
+            <a:pPr marL="0" indent="0">
+              <a:lnSpc>
+                <a:spcPct val="150000"/>
+              </a:lnSpc>
+              <a:buNone/>
+            </a:pPr>
+            <a:r>
+              <a:rPr lang="en-SG" dirty="0"/>
+              <a:t>Context input selections:</a:t>
+            </a:r>
+          </a:p>
+          <a:p>
+            <a:pPr marL="342900" indent="-342900">
+              <a:lnSpc>
+                <a:spcPct val="150000"/>
+              </a:lnSpc>
+              <a:buAutoNum type="arabicParenBoth"/>
+            </a:pPr>
+            <a:r>
+              <a:rPr lang="en-SG" dirty="0"/>
+              <a:t>Original context image with original target image.</a:t>
+            </a:r>
+          </a:p>
+          <a:p>
+            <a:pPr marL="342900" indent="-342900">
+              <a:lnSpc>
+                <a:spcPct val="150000"/>
+              </a:lnSpc>
+              <a:buAutoNum type="arabicParenBoth"/>
+            </a:pPr>
+            <a:r>
+              <a:rPr lang="en-SG" dirty="0"/>
+              <a:t>Original context image with a random target of the same category.</a:t>
+            </a:r>
+          </a:p>
+          <a:p>
+            <a:pPr marL="342900" indent="-342900">
+              <a:lnSpc>
+                <a:spcPct val="150000"/>
+              </a:lnSpc>
+              <a:buAutoNum type="arabicParenBoth"/>
+            </a:pPr>
+            <a:r>
+              <a:rPr lang="en-SG" dirty="0"/>
+              <a:t>Original context image with a black rectangle covering the target region.</a:t>
+            </a:r>
+          </a:p>
+          <a:p>
+            <a:pPr marL="342900" indent="-342900">
+              <a:buAutoNum type="arabicParenBoth"/>
+            </a:pPr>
+            <a:endParaRPr lang="en-SG" dirty="0"/>
+          </a:p>
+        </p:txBody>
+      </p:sp>
+      <p:cxnSp>
+        <p:nvCxnSpPr>
+          <p:cNvPr id="12" name="Straight Connector 11">
+            <a:extLst>
+              <a:ext uri="{FF2B5EF4-FFF2-40B4-BE49-F238E27FC236}">
+                <a16:creationId xmlns:a16="http://schemas.microsoft.com/office/drawing/2014/main" id="{AA2B4E0C-D84B-B27B-CE9D-878B7E0009E1}"/>
+              </a:ext>
+            </a:extLst>
+          </p:cNvPr>
+          <p:cNvCxnSpPr>
+            <a:cxnSpLocks/>
+          </p:cNvCxnSpPr>
+          <p:nvPr/>
+        </p:nvCxnSpPr>
+        <p:spPr>
+          <a:xfrm>
+            <a:off x="6882696" y="3529584"/>
+            <a:ext cx="0" cy="2414016"/>
+          </a:xfrm>
+          <a:prstGeom prst="line">
+            <a:avLst/>
+          </a:prstGeom>
+          <a:ln w="12700"/>
+        </p:spPr>
+        <p:style>
+          <a:lnRef idx="1">
+            <a:schemeClr val="dk1"/>
+          </a:lnRef>
+          <a:fillRef idx="0">
+            <a:schemeClr val="dk1"/>
+          </a:fillRef>
+          <a:effectRef idx="0">
+            <a:schemeClr val="dk1"/>
+          </a:effectRef>
+          <a:fontRef idx="minor">
+            <a:schemeClr val="tx1"/>
+          </a:fontRef>
+        </p:style>
+      </p:cxnSp>
+    </p:spTree>
+    <p:extLst>
+      <p:ext uri="{BB962C8B-B14F-4D97-AF65-F5344CB8AC3E}">
+        <p14:creationId xmlns:p14="http://schemas.microsoft.com/office/powerpoint/2010/main" val="1701272085"/>
+      </p:ext>
+    </p:extLst>
+  </p:cSld>
+  <p:clrMapOvr>
+    <a:masterClrMapping/>
+  </p:clrMapOvr>
+</p:sld>
+</file>
+
+<file path=ppt/slides/slide41.xml><?xml version="1.0" encoding="utf-8"?>
+<p:sld xmlns:a="http://schemas.openxmlformats.org/drawingml/2006/main" xmlns:r="http://schemas.openxmlformats.org/officeDocument/2006/relationships" xmlns:p="http://schemas.openxmlformats.org/presentationml/2006/main">
+  <p:cSld>
+    <p:spTree>
+      <p:nvGrpSpPr>
+        <p:cNvPr id="1" name=""/>
+        <p:cNvGrpSpPr/>
+        <p:nvPr/>
+      </p:nvGrpSpPr>
+      <p:grpSpPr>
+        <a:xfrm>
+          <a:off x="0" y="0"/>
+          <a:ext cx="0" cy="0"/>
+          <a:chOff x="0" y="0"/>
+          <a:chExt cx="0" cy="0"/>
+        </a:xfrm>
+      </p:grpSpPr>
+      <p:sp>
+        <p:nvSpPr>
+          <p:cNvPr id="2" name="Title 1">
+            <a:extLst>
+              <a:ext uri="{FF2B5EF4-FFF2-40B4-BE49-F238E27FC236}">
+                <a16:creationId xmlns:a16="http://schemas.microsoft.com/office/drawing/2014/main" id="{97CC137A-405A-F337-8813-C1DF8DD0173D}"/>
+              </a:ext>
+            </a:extLst>
+          </p:cNvPr>
+          <p:cNvSpPr>
+            <a:spLocks noGrp="1"/>
+          </p:cNvSpPr>
+          <p:nvPr>
+            <p:ph type="title"/>
+          </p:nvPr>
+        </p:nvSpPr>
+        <p:spPr/>
+        <p:txBody>
+          <a:bodyPr/>
+          <a:lstStyle/>
+          <a:p>
+            <a:endParaRPr lang="en-US"/>
+          </a:p>
+        </p:txBody>
+      </p:sp>
+      <p:sp>
+        <p:nvSpPr>
+          <p:cNvPr id="3" name="Content Placeholder 2">
+            <a:extLst>
+              <a:ext uri="{FF2B5EF4-FFF2-40B4-BE49-F238E27FC236}">
+                <a16:creationId xmlns:a16="http://schemas.microsoft.com/office/drawing/2014/main" id="{207B1B8F-A864-80E4-191E-1BAD1C7E9416}"/>
               </a:ext>
             </a:extLst>
           </p:cNvPr>
@@ -35317,37 +35643,14 @@
           <a:bodyPr/>
           <a:lstStyle/>
           <a:p>
-            <a:r>
-              <a:rPr lang="en-US" dirty="0"/>
-              <a:t>We select 18 image categories from the COCO dataset </a:t>
-            </a:r>
-            <a:r>
-              <a:rPr lang="en-SG" dirty="0"/>
-              <a:t>(Lin et al., 2015) and conduct augmentation on both context and target images.</a:t>
-            </a:r>
-          </a:p>
-          <a:p>
-            <a:r>
-              <a:rPr lang="en-SG" dirty="0"/>
-              <a:t>There are 3 selections for Context Image and 3 selections for Target Image to form </a:t>
-            </a:r>
-            <a:r>
-              <a:rPr lang="en-SG"/>
-              <a:t>1 image pair:</a:t>
-            </a:r>
-          </a:p>
-          <a:p>
-            <a:pPr marL="0" indent="0">
-              <a:buNone/>
-            </a:pPr>
-            <a:endParaRPr lang="en-SG" dirty="0"/>
+            <a:endParaRPr lang="en-US"/>
           </a:p>
         </p:txBody>
       </p:sp>
     </p:spTree>
     <p:extLst>
       <p:ext uri="{BB962C8B-B14F-4D97-AF65-F5344CB8AC3E}">
-        <p14:creationId xmlns:p14="http://schemas.microsoft.com/office/powerpoint/2010/main" val="1701272085"/>
+        <p14:creationId xmlns:p14="http://schemas.microsoft.com/office/powerpoint/2010/main" val="867945369"/>
       </p:ext>
     </p:extLst>
   </p:cSld>

</xml_diff>